<commit_message>
refactor: update Rust source code examples and enhance slide content for clarity
</commit_message>
<xml_diff>
--- a/experiments/rust_features/results/slides.pptx
+++ b/experiments/rust_features/results/slides.pptx
@@ -696,7 +696,23 @@
           <a:p/>
           <a:p>
             <a:r>
-              <a:t>--- Rust BOUNDS_CHECK block 1 (slide label: data[i] &gt; data[i-1]) ---</a:t>
+              <a:t>Each bounds check block does: load index, load slice.len(), cmp, jae panic.</a:t>
+            </a:r>
+          </a:p>
+          <a:p>
+            <a:r>
+              <a:t>If index &lt; len: fall through to actual memory access (success).</a:t>
+            </a:r>
+          </a:p>
+          <a:p>
+            <a:r>
+              <a:t>If index &gt;= len: jump to panic handler (lea panic_msg + call panic).</a:t>
+            </a:r>
+          </a:p>
+          <a:p/>
+          <a:p>
+            <a:r>
+              <a:t>--- Rust BOUNDS_CHECK block 1 (for data[i] access on line 968) ---</a:t>
             </a:r>
           </a:p>
           <a:p>
@@ -706,6 +722,11 @@
           </a:p>
           <a:p>
             <a:r>
+              <a:t>  rax = index (i), rcx = slice.len(). If i &lt; len, continue; else panic.</a:t>
+            </a:r>
+          </a:p>
+          <a:p>
+            <a:r>
               <a:t>0x46f085: mov      rax, qword ptr [rsp + 0x68]</a:t>
             </a:r>
           </a:p>
@@ -724,10 +745,15 @@
               <a:t>0x46f095: jb       0x46f0ae</a:t>
             </a:r>
           </a:p>
+          <a:p>
+            <a:r>
+              <a:t>  → jb (jump if below): index &lt; len → success, proceed to access data[i]</a:t>
+            </a:r>
+          </a:p>
           <a:p/>
           <a:p>
             <a:r>
-              <a:t>--- Rust BOUNDS_CHECK block 2 (slide label: data[i] &gt; data[i+1]) ---</a:t>
+              <a:t>--- Rust BOUNDS_CHECK block 2 (for data[i-1] access on line 968) ---</a:t>
             </a:r>
           </a:p>
           <a:p>
@@ -737,6 +763,11 @@
           </a:p>
           <a:p>
             <a:r>
+              <a:t>  rax = index (i-1 or i+1), rcx = slice.len(). If &gt;= len, jump to panic.</a:t>
+            </a:r>
+          </a:p>
+          <a:p>
+            <a:r>
               <a:t>0x46f0ed: mov      rax, qword ptr [rsp + 0x70]</a:t>
             </a:r>
           </a:p>
@@ -755,15 +786,25 @@
               <a:t>0x46f0fd: jae      0x46f128</a:t>
             </a:r>
           </a:p>
+          <a:p>
+            <a:r>
+              <a:t>  → jae (jump if above/equal): index &gt;= len → panic</a:t>
+            </a:r>
+          </a:p>
+          <a:p>
+            <a:r>
+              <a:t>  Target 0x46f128 is: lea rdx,[rip+panic_msg]; call panic_handler</a:t>
+            </a:r>
+          </a:p>
           <a:p/>
           <a:p>
             <a:r>
-              <a:t>--- Rust BOUNDS_CHECK block 3 (slide label: data[j] &lt; lmin) ---</a:t>
-            </a:r>
-          </a:p>
-          <a:p>
-            <a:r>
-              <a:t>Source line 968: if data[i] &gt; data[i - 1] &amp;&amp; data[i] &gt; data[i + 1]</a:t>
+              <a:t>--- Rust BOUNDS_CHECK block 3 (for data[i+1] access on line 968) ---</a:t>
+            </a:r>
+          </a:p>
+          <a:p>
+            <a:r>
+              <a:t>Source line 968: same line, third array access</a:t>
             </a:r>
           </a:p>
           <a:p>
@@ -794,7 +835,7 @@
           </a:p>
           <a:p>
             <a:r>
-              <a:t>Block 4 [line 969: let mut left_min = data[i]]:</a:t>
+              <a:t>Block 4 [line 969: let mut left_min = data[i] — check i &lt; len]:</a:t>
             </a:r>
           </a:p>
           <a:p>
@@ -820,7 +861,7 @@
           <a:p/>
           <a:p>
             <a:r>
-              <a:t>Block 5 [line 974: if data[i] - left_min &gt;= min_prominence]:</a:t>
+              <a:t>Block 5 [line 974: if data[i] - left_min — check i &lt; len]:</a:t>
             </a:r>
           </a:p>
           <a:p>
@@ -846,7 +887,7 @@
           <a:p/>
           <a:p>
             <a:r>
-              <a:t>Block 6 [line 972: if data[j] &gt; data[i] { break; }]:</a:t>
+              <a:t>Block 6 [line 972: if data[j] &gt; data[i] — check j &lt; len]:</a:t>
             </a:r>
           </a:p>
           <a:p>
@@ -872,7 +913,7 @@
           <a:p/>
           <a:p>
             <a:r>
-              <a:t>Block 7 [line 971: if data[j] &lt; left_min { left_min = data[j]; }]:</a:t>
+              <a:t>Block 7 [line 971: if data[j] &lt; left_min — check j &lt; len]:</a:t>
             </a:r>
           </a:p>
           <a:p>
@@ -898,7 +939,7 @@
           <a:p/>
           <a:p>
             <a:r>
-              <a:t>Block 8 [line 974: if data[i] - left_min &gt;= min_prominence]:</a:t>
+              <a:t>Block 8 [line 974: data[i] access — check i &lt; len]:</a:t>
             </a:r>
           </a:p>
           <a:p>
@@ -924,7 +965,7 @@
           <a:p/>
           <a:p>
             <a:r>
-              <a:t>Block 9 [line 975: peaks.push((i, data[i]))]:</a:t>
+              <a:t>Block 9 [line 975: peaks.push((i, data[i])) — check i &lt; len]:</a:t>
             </a:r>
           </a:p>
           <a:p>
@@ -950,63 +991,159 @@
           <a:p/>
           <a:p>
             <a:r>
-              <a:t>--- C block 1 shown (BOUNDS_CHECK, 3 insns) ---</a:t>
-            </a:r>
-          </a:p>
-          <a:p>
-            <a:r>
-              <a:t>Source line 773: for (size_t j = i; j &gt; 0; j--)</a:t>
-            </a:r>
-          </a:p>
-          <a:p>
-            <a:r>
-              <a:t>0x405571: sub      qword ptr [rbp - 0x20], 1</a:t>
-            </a:r>
-          </a:p>
-          <a:p>
-            <a:r>
-              <a:t>0x405576: cmp      qword ptr [rbp - 0x20], 0</a:t>
-            </a:r>
-          </a:p>
-          <a:p>
-            <a:r>
-              <a:t>0x40557b: jne      0x40550a</a:t>
+              <a:t>--- Example panic target (where jae jumps to on bounds check failure) ---</a:t>
+            </a:r>
+          </a:p>
+          <a:p>
+            <a:r>
+              <a:t>Target of block 2's jae 0x46f128:</a:t>
+            </a:r>
+          </a:p>
+          <a:p>
+            <a:r>
+              <a:t>0x46f128: mov      rsi, qword ptr [rsp + 0xa8]</a:t>
+            </a:r>
+          </a:p>
+          <a:p>
+            <a:r>
+              <a:t>0x46f130: mov      rdi, qword ptr [rsp + 0x70]</a:t>
+            </a:r>
+          </a:p>
+          <a:p>
+            <a:r>
+              <a:t>0x46f135: lea      rdx, [rip + 0x58cf4]</a:t>
+            </a:r>
+          </a:p>
+          <a:p>
+            <a:r>
+              <a:t>0x46f13c: mov      rax, qword ptr [rip + 0x5d43d]</a:t>
+            </a:r>
+          </a:p>
+          <a:p>
+            <a:r>
+              <a:t>0x46f143: call     rax</a:t>
+            </a:r>
+          </a:p>
+          <a:p>
+            <a:r>
+              <a:t>  → loads panic message ("index out of bounds") and calls core::panicking::panic_bounds_check</a:t>
             </a:r>
           </a:p>
           <a:p/>
           <a:p>
             <a:r>
-              <a:t>--- C block 2 shown (ITERATOR_STATE, 5 insns) ---</a:t>
-            </a:r>
-          </a:p>
-          <a:p>
-            <a:r>
-              <a:t>Source line 770: for (size_t i = 1; i+1 &lt; n; i++)</a:t>
-            </a:r>
-          </a:p>
-          <a:p>
-            <a:r>
-              <a:t>0x4055a5: add      qword ptr [rbp - 0x10], 1</a:t>
-            </a:r>
-          </a:p>
-          <a:p>
-            <a:r>
-              <a:t>0x4055aa: mov      rax, qword ptr [rbp - 0x10]</a:t>
-            </a:r>
-          </a:p>
-          <a:p>
-            <a:r>
-              <a:t>0x4055ae: add      rax, 1</a:t>
-            </a:r>
-          </a:p>
-          <a:p>
-            <a:r>
-              <a:t>0x4055b2: cmp      qword ptr [rbp - 0x30], rax</a:t>
-            </a:r>
-          </a:p>
-          <a:p>
-            <a:r>
-              <a:t>0x4055b6: ja       0x405478</a:t>
+              <a:t>--- C block 1 shown (8 insns) ---</a:t>
+            </a:r>
+          </a:p>
+          <a:p>
+            <a:r>
+              <a:t>Source lines 768-770: function prologue + variable init + for loop start</a:t>
+            </a:r>
+          </a:p>
+          <a:p>
+            <a:r>
+              <a:t>  C has NO array bounds checking — raw pointer access.</a:t>
+            </a:r>
+          </a:p>
+          <a:p>
+            <a:r>
+              <a:t>0x405453: push     rbp</a:t>
+            </a:r>
+          </a:p>
+          <a:p>
+            <a:r>
+              <a:t>0x405454: mov      rbp, rsp</a:t>
+            </a:r>
+          </a:p>
+          <a:p>
+            <a:r>
+              <a:t>0x405457: mov      qword ptr [rbp - 0x28], rdi</a:t>
+            </a:r>
+          </a:p>
+          <a:p>
+            <a:r>
+              <a:t>0x40545b: mov      qword ptr [rbp - 0x30], rsi</a:t>
+            </a:r>
+          </a:p>
+          <a:p>
+            <a:r>
+              <a:t>0x40545f: mov      qword ptr [rbp - 0x38], rdx</a:t>
+            </a:r>
+          </a:p>
+          <a:p>
+            <a:r>
+              <a:t>0x405463: mov      qword ptr [rbp - 8], 0</a:t>
+            </a:r>
+          </a:p>
+          <a:p>
+            <a:r>
+              <a:t>0x40546b: mov      qword ptr [rbp - 0x10], 1</a:t>
+            </a:r>
+          </a:p>
+          <a:p>
+            <a:r>
+              <a:t>0x405473: jmp      0x4055aa</a:t>
+            </a:r>
+          </a:p>
+          <a:p/>
+          <a:p>
+            <a:r>
+              <a:t>--- C block 2 shown (8 insns) ---</a:t>
+            </a:r>
+          </a:p>
+          <a:p>
+            <a:r>
+              <a:t>Source line 774: if (data[j-1] &lt; lmin) lmin = data[j-1];</a:t>
+            </a:r>
+          </a:p>
+          <a:p>
+            <a:r>
+              <a:t>  Direct pointer arithmetic: shl+lea to compute offset, then load.</a:t>
+            </a:r>
+          </a:p>
+          <a:p>
+            <a:r>
+              <a:t>  No cmp-index-vs-length — just raw memory access.</a:t>
+            </a:r>
+          </a:p>
+          <a:p>
+            <a:r>
+              <a:t>0x40550a: mov      rax, qword ptr [rbp - 0x20]</a:t>
+            </a:r>
+          </a:p>
+          <a:p>
+            <a:r>
+              <a:t>0x40550e: shl      rax, 3</a:t>
+            </a:r>
+          </a:p>
+          <a:p>
+            <a:r>
+              <a:t>0x405512: lea      rdx, [rax - 8]</a:t>
+            </a:r>
+          </a:p>
+          <a:p>
+            <a:r>
+              <a:t>0x405516: mov      rax, qword ptr [rbp - 0x28]</a:t>
+            </a:r>
+          </a:p>
+          <a:p>
+            <a:r>
+              <a:t>0x40551a: add      rax, rdx</a:t>
+            </a:r>
+          </a:p>
+          <a:p>
+            <a:r>
+              <a:t>0x40551d: mov      rax, qword ptr [rax]</a:t>
+            </a:r>
+          </a:p>
+          <a:p>
+            <a:r>
+              <a:t>0x405520: cmp      qword ptr [rbp - 0x18], rax</a:t>
+            </a:r>
+          </a:p>
+          <a:p>
+            <a:r>
+              <a:t>0x405524: jbe      0x405540</a:t>
             </a:r>
           </a:p>
         </p:txBody>
@@ -1740,7 +1877,7 @@
           <a:p/>
           <a:p>
             <a:r>
-              <a:t>--- Rust: Step 1 check block (shown on slide) ---</a:t>
+              <a:t>--- Rust: check block (0x47bf85) — is Option None? (shown on slide) ---</a:t>
             </a:r>
           </a:p>
           <a:p>
@@ -1750,6 +1887,16 @@
           </a:p>
           <a:p>
             <a:r>
+              <a:t>  cmp rdx,0: checks if Option is None. If not None → jne to 0x47bfc8 (success).</a:t>
+            </a:r>
+          </a:p>
+          <a:p>
+            <a:r>
+              <a:t>  If None → falls through to panic block at 0x47bfb4.</a:t>
+            </a:r>
+          </a:p>
+          <a:p>
+            <a:r>
               <a:t>0x47bf85: mov      rax, qword ptr [rsp + 0xc0]</a:t>
             </a:r>
           </a:p>
@@ -1796,7 +1943,43 @@
           <a:p/>
           <a:p>
             <a:r>
-              <a:t>--- Rust: Step 2 extract block (shown on slide) ---</a:t>
+              <a:t>--- Rust: panic block (0x47bfb4) — lea panic_msg + call panic (shown on slide) ---</a:t>
+            </a:r>
+          </a:p>
+          <a:p>
+            <a:r>
+              <a:t>Source: compiler-generated for .unwrap() panic path (line 1603)</a:t>
+            </a:r>
+          </a:p>
+          <a:p>
+            <a:r>
+              <a:t>  Opcodes: {call, lea, mov} — SAME as normal function calls.</a:t>
+            </a:r>
+          </a:p>
+          <a:p>
+            <a:r>
+              <a:t>  This is the key problem: matcher can't distinguish panic from real calls.</a:t>
+            </a:r>
+          </a:p>
+          <a:p>
+            <a:r>
+              <a:t>0x47bfb4: lea      rdi, [rip + 0x4d39d]</a:t>
+            </a:r>
+          </a:p>
+          <a:p>
+            <a:r>
+              <a:t>0x47bfbb: mov      rax, qword ptr [rip + 0x506fe]</a:t>
+            </a:r>
+          </a:p>
+          <a:p>
+            <a:r>
+              <a:t>0x47bfc2: call     rax</a:t>
+            </a:r>
+          </a:p>
+          <a:p/>
+          <a:p>
+            <a:r>
+              <a:t>--- Rust: normal call block — collect() (shown on slide for CONTRAST) ---</a:t>
             </a:r>
           </a:p>
           <a:p>
@@ -1806,6 +1989,16 @@
           </a:p>
           <a:p>
             <a:r>
+              <a:t>  Opcodes: {call, lea, mov} — SAME as the panic block above!</a:t>
+            </a:r>
+          </a:p>
+          <a:p>
+            <a:r>
+              <a:t>  This demonstrates why the matcher pairs them incorrectly.</a:t>
+            </a:r>
+          </a:p>
+          <a:p>
+            <a:r>
               <a:t>0x47bf02: mov      rsi, qword ptr [rsp + 0xc8]</a:t>
             </a:r>
           </a:p>
@@ -1827,69 +2020,43 @@
           <a:p/>
           <a:p>
             <a:r>
-              <a:t>--- Rust: Step 3 panic block (shown on slide) ---</a:t>
-            </a:r>
-          </a:p>
-          <a:p>
-            <a:r>
-              <a:t>Source: compiler-generated for .unwrap() panic path (line 1603)</a:t>
-            </a:r>
-          </a:p>
-          <a:p>
-            <a:r>
-              <a:t>0x47bfb4: lea      rdi, [rip + 0x4d39d]</a:t>
-            </a:r>
-          </a:p>
-          <a:p>
-            <a:r>
-              <a:t>0x47bfbb: mov      rax, qword ptr [rip + 0x506fe]</a:t>
-            </a:r>
-          </a:p>
-          <a:p>
-            <a:r>
-              <a:t>0x47bfc2: call     rax</a:t>
+              <a:t>--- C block 1 shown ---</a:t>
+            </a:r>
+          </a:p>
+          <a:p>
+            <a:r>
+              <a:t>Source lines 1282-1283: strncpy(copy, s, 1023); copy[1023] = '\0';</a:t>
+            </a:r>
+          </a:p>
+          <a:p>
+            <a:r>
+              <a:t>0x407fd6: mov      byte ptr [rbp - 0x831], 0</a:t>
+            </a:r>
+          </a:p>
+          <a:p>
+            <a:r>
+              <a:t>0x407fdd: lea      rax, [rbp - 0xc30]</a:t>
+            </a:r>
+          </a:p>
+          <a:p>
+            <a:r>
+              <a:t>0x407fe4: mov      esi, 0x40b019</a:t>
+            </a:r>
+          </a:p>
+          <a:p>
+            <a:r>
+              <a:t>0x407fe9: mov      rdi, rax</a:t>
+            </a:r>
+          </a:p>
+          <a:p>
+            <a:r>
+              <a:t>0x407fec: call     0x401110</a:t>
             </a:r>
           </a:p>
           <a:p/>
           <a:p>
             <a:r>
-              <a:t>--- C block 1 shown (BODY, 5 insns) ---</a:t>
-            </a:r>
-          </a:p>
-          <a:p>
-            <a:r>
-              <a:t>Source lines 1282-1283: strncpy(copy, s, 1023); copy[1023] = '\0';</a:t>
-            </a:r>
-          </a:p>
-          <a:p>
-            <a:r>
-              <a:t>0x407fd6: mov      byte ptr [rbp - 0x831], 0</a:t>
-            </a:r>
-          </a:p>
-          <a:p>
-            <a:r>
-              <a:t>0x407fdd: lea      rax, [rbp - 0xc30]</a:t>
-            </a:r>
-          </a:p>
-          <a:p>
-            <a:r>
-              <a:t>0x407fe4: mov      esi, 0x40b019</a:t>
-            </a:r>
-          </a:p>
-          <a:p>
-            <a:r>
-              <a:t>0x407fe9: mov      rdi, rax</a:t>
-            </a:r>
-          </a:p>
-          <a:p>
-            <a:r>
-              <a:t>0x407fec: call     0x401110</a:t>
-            </a:r>
-          </a:p>
-          <a:p/>
-          <a:p>
-            <a:r>
-              <a:t>--- C block 2 shown (BODY, 2 insns) ---</a:t>
+              <a:t>--- C block 2 shown ---</a:t>
             </a:r>
           </a:p>
           <a:p>
@@ -8787,7 +8954,7 @@
         <p:spPr>
           <a:xfrm>
             <a:off x="274320" y="1371600"/>
-            <a:ext cx="5303520" cy="1371600"/>
+            <a:ext cx="5303520" cy="1645920"/>
           </a:xfrm>
           <a:prstGeom prst="roundRect">
             <a:avLst/>
@@ -8831,7 +8998,7 @@
               </a:defRPr>
             </a:pPr>
             <a:r>
-              <a:t>Rust source — each data[x] inserts a bounds check</a:t>
+              <a:t>Rust source — every data[x] inserts a bounds check (index &lt; len)</a:t>
             </a:r>
           </a:p>
           <a:p>
@@ -8848,15 +9015,15 @@
             </a:r>
             <a:br/>
             <a:r>
-              <a:t>    if data[i] &gt; data[i-1]    // ← bounds check</a:t>
-            </a:r>
-            <a:br/>
-            <a:r>
-              <a:t>    &amp;&amp; data[i] &gt; data[i+1] {  // ← bounds check</a:t>
-            </a:r>
-            <a:br/>
-            <a:r>
-              <a:t>        let mut lmin = data[i]; // ← bounds check</a:t>
+              <a:t>    if data[i] &gt; data[i-1]     // data[i]: cmp i,len; jae panic</a:t>
+            </a:r>
+            <a:br/>
+            <a:r>
+              <a:t>    &amp;&amp; data[i] &gt; data[i+1] {   // data[i-1]: cmp (i-1),len; jae panic</a:t>
+            </a:r>
+            <a:br/>
+            <a:r>
+              <a:t>        let mut lmin = data[i]; // data[i+1]: cmp (i+1),len; jae panic</a:t>
             </a:r>
             <a:br/>
             <a:r>
@@ -8864,7 +9031,15 @@
             </a:r>
             <a:br/>
             <a:r>
-              <a:t>            if data[j] &lt; lmin   // ← bounds check</a:t>
+              <a:t>            if data[j] &lt; lmin   // data[j]: cmp j,len; jae panic</a:t>
+            </a:r>
+            <a:br/>
+            <a:r>
+              <a:t>// Each data[x] → compiler inserts: load index, load len,</a:t>
+            </a:r>
+            <a:br/>
+            <a:r>
+              <a:t>//   cmp index,len; jae panic_handler. Success → access memory.</a:t>
             </a:r>
           </a:p>
         </p:txBody>
@@ -8900,7 +9075,7 @@
               </a:defRPr>
             </a:pPr>
             <a:r>
-              <a:t>Rust assembly — 3 of 9 bounds check blocks (all identical opcodes):</a:t>
+              <a:t>Rust assembly — 3 of 9 bounds check blocks (cmp index,len; jae panic):</a:t>
             </a:r>
           </a:p>
         </p:txBody>
@@ -8958,7 +9133,7 @@
               </a:defRPr>
             </a:pPr>
             <a:r>
-              <a:t>← data[i] &gt; data[i-1]</a:t>
+              <a:t>← data[i] access: cmp index, len</a:t>
             </a:r>
           </a:p>
           <a:p>
@@ -9041,7 +9216,7 @@
               </a:defRPr>
             </a:pPr>
             <a:r>
-              <a:t>← data[i] &gt; data[i+1]</a:t>
+              <a:t>← data[i-1] access: cmp index, len</a:t>
             </a:r>
           </a:p>
           <a:p>
@@ -9124,7 +9299,7 @@
               </a:defRPr>
             </a:pPr>
             <a:r>
-              <a:t>← data[j] &lt; lmin</a:t>
+              <a:t>← data[i+1] access: cmp index, len</a:t>
             </a:r>
           </a:p>
           <a:p>
@@ -9304,7 +9479,7 @@
               </a:defRPr>
             </a:pPr>
             <a:r>
-              <a:t>C assembly — diverse block types:</a:t>
+              <a:t>C assembly — no bounds checks, blocks are diverse:</a:t>
             </a:r>
           </a:p>
         </p:txBody>
@@ -9318,7 +9493,7 @@
         <p:spPr>
           <a:xfrm>
             <a:off x="5760720" y="2880360"/>
-            <a:ext cx="3200400" cy="694944"/>
+            <a:ext cx="3200400" cy="1426464"/>
           </a:xfrm>
           <a:prstGeom prst="roundRect">
             <a:avLst/>
@@ -9362,7 +9537,7 @@
               </a:defRPr>
             </a:pPr>
             <a:r>
-              <a:t>BOUNDS_CHECK (3 insns)</a:t>
+              <a:t>8 insns (line 768)</a:t>
             </a:r>
           </a:p>
           <a:p>
@@ -9375,15 +9550,35 @@
               </a:defRPr>
             </a:pPr>
             <a:r>
-              <a:t>sub      qword ptr [rbp - 0x20], 1</a:t>
-            </a:r>
-            <a:br/>
-            <a:r>
-              <a:t>cmp      qword ptr [rbp - 0x20], 0</a:t>
-            </a:r>
-            <a:br/>
-            <a:r>
-              <a:t>jne      0x40550a</a:t>
+              <a:t>push     rbp</a:t>
+            </a:r>
+            <a:br/>
+            <a:r>
+              <a:t>mov      rbp, rsp</a:t>
+            </a:r>
+            <a:br/>
+            <a:r>
+              <a:t>mov      qword ptr [rbp - 0x28], rdi</a:t>
+            </a:r>
+            <a:br/>
+            <a:r>
+              <a:t>mov      qword ptr [rbp - 0x30], rsi</a:t>
+            </a:r>
+            <a:br/>
+            <a:r>
+              <a:t>mov      qword ptr [rbp - 0x38], rdx</a:t>
+            </a:r>
+            <a:br/>
+            <a:r>
+              <a:t>mov      qword ptr [rbp - 8], 0</a:t>
+            </a:r>
+            <a:br/>
+            <a:r>
+              <a:t>mov      qword ptr [rbp - 0x10], 1</a:t>
+            </a:r>
+            <a:br/>
+            <a:r>
+              <a:t>jmp      0x4055aa</a:t>
             </a:r>
           </a:p>
         </p:txBody>
@@ -9396,8 +9591,8 @@
         </p:nvSpPr>
         <p:spPr>
           <a:xfrm>
-            <a:off x="5760720" y="3621024"/>
-            <a:ext cx="3200400" cy="987552"/>
+            <a:off x="5760720" y="4352544"/>
+            <a:ext cx="3200400" cy="1426464"/>
           </a:xfrm>
           <a:prstGeom prst="roundRect">
             <a:avLst/>
@@ -9441,7 +9636,7 @@
               </a:defRPr>
             </a:pPr>
             <a:r>
-              <a:t>ITERATOR_STATE (5 insns)</a:t>
+              <a:t>8 insns (line 774)</a:t>
             </a:r>
           </a:p>
           <a:p>
@@ -9454,23 +9649,35 @@
               </a:defRPr>
             </a:pPr>
             <a:r>
-              <a:t>add      qword ptr [rbp - 0x10], 1</a:t>
-            </a:r>
-            <a:br/>
-            <a:r>
-              <a:t>mov      rax, qword ptr [rbp - 0x10]</a:t>
-            </a:r>
-            <a:br/>
-            <a:r>
-              <a:t>add      rax, 1</a:t>
-            </a:r>
-            <a:br/>
-            <a:r>
-              <a:t>cmp      qword ptr [rbp - 0x30], rax</a:t>
-            </a:r>
-            <a:br/>
-            <a:r>
-              <a:t>ja       0x405478</a:t>
+              <a:t>mov      rax, qword ptr [rbp - 0x20]</a:t>
+            </a:r>
+            <a:br/>
+            <a:r>
+              <a:t>shl      rax, 3</a:t>
+            </a:r>
+            <a:br/>
+            <a:r>
+              <a:t>lea      rdx, [rax - 8]</a:t>
+            </a:r>
+            <a:br/>
+            <a:r>
+              <a:t>mov      rax, qword ptr [rbp - 0x28]</a:t>
+            </a:r>
+            <a:br/>
+            <a:r>
+              <a:t>add      rax, rdx</a:t>
+            </a:r>
+            <a:br/>
+            <a:r>
+              <a:t>mov      rax, qword ptr [rax]</a:t>
+            </a:r>
+            <a:br/>
+            <a:r>
+              <a:t>cmp      qword ptr [rbp - 0x18], rax</a:t>
+            </a:r>
+            <a:br/>
+            <a:r>
+              <a:t>jbe      0x405540</a:t>
             </a:r>
           </a:p>
         </p:txBody>
@@ -9483,7 +9690,7 @@
         </p:nvSpPr>
         <p:spPr>
           <a:xfrm>
-            <a:off x="5760720" y="4654296"/>
+            <a:off x="5760720" y="5824728"/>
             <a:ext cx="3200400" cy="457200"/>
           </a:xfrm>
           <a:prstGeom prst="rect">
@@ -9506,7 +9713,7 @@
               </a:defRPr>
             </a:pPr>
             <a:r>
-              <a:t>↑ Different opcodes per block → matcher distinguishes them</a:t>
+              <a:t>↑ No bounds checks — blocks have different opcodes</a:t>
             </a:r>
           </a:p>
         </p:txBody>
@@ -9780,20 +9987,24 @@
               </a:defRPr>
             </a:pPr>
             <a:r>
-              <a:t>9 identical bounds check blocks</a:t>
-            </a:r>
-            <a:br/>
-            <a:r>
-              <a:t>→ matcher pairs wrong ones</a:t>
-            </a:r>
-            <a:br/>
-            <a:r>
-              <a:t>with high confidence.</a:t>
-            </a:r>
-            <a:br/>
-            <a:br/>
-            <a:r>
-              <a:t>C has no bounds checks →</a:t>
+              <a:t>9 bounds check blocks:</a:t>
+            </a:r>
+            <a:br/>
+            <a:r>
+              <a:t>each does cmp index,len;</a:t>
+            </a:r>
+            <a:br/>
+            <a:r>
+              <a:t>jae panic. All identical</a:t>
+            </a:r>
+            <a:br/>
+            <a:r>
+              <a:t>opcodes {cmp, jcc, mov}.</a:t>
+            </a:r>
+            <a:br/>
+            <a:br/>
+            <a:r>
+              <a:t>C: raw pointer, no checks →</a:t>
             </a:r>
             <a:br/>
             <a:r>
@@ -9986,7 +10197,7 @@
             </a:r>
             <a:br/>
             <a:r>
-              <a:t>    // ... 7 uses of ? total</a:t>
+              <a:t>    // ... 6 uses of ? total</a:t>
             </a:r>
           </a:p>
         </p:txBody>
@@ -10022,7 +10233,7 @@
               </a:defRPr>
             </a:pPr>
             <a:r>
-              <a:t>Rust assembly — 8 identical error-return blocks (of 53 total):</a:t>
+              <a:t>Rust assembly — 8 identical error-return blocks (of 49 O0 blocks):</a:t>
             </a:r>
           </a:p>
         </p:txBody>
@@ -10521,7 +10732,7 @@
               </a:defRPr>
             </a:pPr>
             <a:r>
-              <a:t>C assembly — 9 blocks, 92% unique opcodes:</a:t>
+              <a:t>C assembly — 9 O0 blocks, diverse opcodes:</a:t>
             </a:r>
           </a:p>
         </p:txBody>
@@ -10579,7 +10790,7 @@
               </a:defRPr>
             </a:pPr>
             <a:r>
-              <a:t>BODY (7 insns)</a:t>
+              <a:t>7 insns (line 1025)</a:t>
             </a:r>
           </a:p>
           <a:p>
@@ -10674,7 +10885,7 @@
               </a:defRPr>
             </a:pPr>
             <a:r>
-              <a:t>BODY (2 insns)</a:t>
+              <a:t>2 insns (line 1026)</a:t>
             </a:r>
           </a:p>
           <a:p>
@@ -10705,7 +10916,7 @@
         <p:spPr>
           <a:xfrm>
             <a:off x="5760720" y="4617720"/>
-            <a:ext cx="3200400" cy="548640"/>
+            <a:ext cx="3200400" cy="694944"/>
           </a:xfrm>
           <a:prstGeom prst="roundRect">
             <a:avLst/>
@@ -10749,7 +10960,7 @@
               </a:defRPr>
             </a:pPr>
             <a:r>
-              <a:t>BODY (2 insns)</a:t>
+              <a:t>3 insns (line 1031)</a:t>
             </a:r>
           </a:p>
           <a:p>
@@ -10762,11 +10973,15 @@
               </a:defRPr>
             </a:pPr>
             <a:r>
-              <a:t>mov      eax, 0</a:t>
-            </a:r>
-            <a:br/>
-            <a:r>
-              <a:t>jmp      0x406cc9</a:t>
+              <a:t>mov      rax, qword ptr [rbp - 0x18]</a:t>
+            </a:r>
+            <a:br/>
+            <a:r>
+              <a:t>sub      rax, qword ptr [rbp - 0x28]</a:t>
+            </a:r>
+            <a:br/>
+            <a:r>
+              <a:t>jmp      0x406cae</a:t>
             </a:r>
           </a:p>
         </p:txBody>
@@ -10779,7 +10994,7 @@
         </p:nvSpPr>
         <p:spPr>
           <a:xfrm>
-            <a:off x="5760720" y="5212080"/>
+            <a:off x="5760720" y="5358384"/>
             <a:ext cx="3200400" cy="457200"/>
           </a:xfrm>
           <a:prstGeom prst="rect">
@@ -11076,25 +11291,25 @@
               </a:defRPr>
             </a:pPr>
             <a:r>
-              <a:t>53 Rust blocks, only 28% unique</a:t>
-            </a:r>
-            <a:br/>
-            <a:r>
-              <a:t>opcode sets.</a:t>
-            </a:r>
-            <a:br/>
-            <a:br/>
-            <a:r>
-              <a:t>7 uses of ? → 7+ identical</a:t>
-            </a:r>
-            <a:br/>
-            <a:r>
-              <a:t>error-propagation blocks.</a:t>
-            </a:r>
-            <a:br/>
-            <a:br/>
-            <a:r>
-              <a:t>C: 13 blocks, 92% unique.</a:t>
+              <a:t>49 Rust O0 blocks, only 22%</a:t>
+            </a:r>
+            <a:br/>
+            <a:r>
+              <a:t>unique opcode sets.</a:t>
+            </a:r>
+            <a:br/>
+            <a:br/>
+            <a:r>
+              <a:t>6 uses of ? → 8 identical</a:t>
+            </a:r>
+            <a:br/>
+            <a:r>
+              <a:t>error-return blocks.</a:t>
+            </a:r>
+            <a:br/>
+            <a:br/>
+            <a:r>
+              <a:t>C: 9 O0 blocks, 89% unique.</a:t>
             </a:r>
             <a:br/>
             <a:r>
@@ -11196,7 +11411,7 @@
               </a:defRPr>
             </a:pPr>
             <a:r>
-              <a:t>.unwrap() expands into check + extract + panic-call — all sharing the same opcodes</a:t>
+              <a:t>.unwrap() inserts check + panic blocks — panic blocks look like normal call blocks</a:t>
             </a:r>
           </a:p>
         </p:txBody>
@@ -11210,7 +11425,7 @@
         <p:spPr>
           <a:xfrm>
             <a:off x="274320" y="1371600"/>
-            <a:ext cx="5303520" cy="1188720"/>
+            <a:ext cx="5303520" cy="1371600"/>
           </a:xfrm>
           <a:prstGeom prst="roundRect">
             <a:avLst/>
@@ -11254,7 +11469,7 @@
               </a:defRPr>
             </a:pPr>
             <a:r>
-              <a:t>Rust — each .unwrap() generates 3 blocks</a:t>
+              <a:t>Rust source — .unwrap() inserts check + panic blocks</a:t>
             </a:r>
           </a:p>
           <a:p>
@@ -11267,19 +11482,31 @@
               </a:defRPr>
             </a:pPr>
             <a:r>
-              <a:t>let first = parts.first().unwrap(); // ← 3 blocks</a:t>
-            </a:r>
-            <a:br/>
-            <a:r>
-              <a:t>let last = parts.last().unwrap();   // ← 3 blocks</a:t>
-            </a:r>
-            <a:br/>
-            <a:r>
-              <a:t>let mid = parts.get(parts.len()/2)</a:t>
-            </a:r>
-            <a:br/>
-            <a:r>
-              <a:t>                .unwrap();          // ← 3 blocks</a:t>
+              <a:t>fn pu_08(s: &amp;str) -&gt; u64 {</a:t>
+            </a:r>
+            <a:br/>
+            <a:r>
+              <a:t>    let parts: Vec&lt;&amp;str&gt; = s.split_whitespace().collect();</a:t>
+            </a:r>
+            <a:br/>
+            <a:r>
+              <a:t>    let first = parts.first().unwrap(); // check+panic</a:t>
+            </a:r>
+            <a:br/>
+            <a:r>
+              <a:t>    let last = parts.last().unwrap();   // check+panic</a:t>
+            </a:r>
+            <a:br/>
+            <a:r>
+              <a:t>    let mid = parts.get(parts.len()/2).unwrap(); // check+panic</a:t>
+            </a:r>
+            <a:br/>
+            <a:r>
+              <a:t>// Each .unwrap(): check discriminant → if None, call panic</a:t>
+            </a:r>
+            <a:br/>
+            <a:r>
+              <a:t>// Panic block uses {lea, mov, call} — same as normal calls</a:t>
             </a:r>
           </a:p>
         </p:txBody>
@@ -11292,7 +11519,7 @@
         </p:nvSpPr>
         <p:spPr>
           <a:xfrm>
-            <a:off x="274320" y="2697480"/>
+            <a:off x="274320" y="2880360"/>
             <a:ext cx="5303520" cy="274320"/>
           </a:xfrm>
           <a:prstGeom prst="rect">
@@ -11315,7 +11542,7 @@
               </a:defRPr>
             </a:pPr>
             <a:r>
-              <a:t>Rust assembly — what one .unwrap() expands to:</a:t>
+              <a:t>Rust assembly — .unwrap() expansion + a normal call block:</a:t>
             </a:r>
           </a:p>
         </p:txBody>
@@ -11328,7 +11555,7 @@
         </p:nvSpPr>
         <p:spPr>
           <a:xfrm>
-            <a:off x="274320" y="2971800"/>
+            <a:off x="274320" y="3154680"/>
             <a:ext cx="4572000" cy="1572768"/>
           </a:xfrm>
           <a:prstGeom prst="roundRect">
@@ -11373,7 +11600,7 @@
               </a:defRPr>
             </a:pPr>
             <a:r>
-              <a:t>Step 1: check if None</a:t>
+              <a:t>check: is Option None? (cmp rdx,0 → if None, fall to panic)</a:t>
             </a:r>
           </a:p>
           <a:p>
@@ -11431,8 +11658,8 @@
         </p:nvSpPr>
         <p:spPr>
           <a:xfrm>
-            <a:off x="274320" y="4590288"/>
-            <a:ext cx="4572000" cy="841248"/>
+            <a:off x="274320" y="4773168"/>
+            <a:ext cx="4572000" cy="694944"/>
           </a:xfrm>
           <a:prstGeom prst="roundRect">
             <a:avLst/>
@@ -11470,13 +11697,13 @@
               </a:spcAft>
               <a:defRPr sz="1300" b="1">
                 <a:solidFill>
-                  <a:srgbClr val="0E5AAB"/>
-                </a:solidFill>
-                <a:latin typeface="Calibri"/>
-              </a:defRPr>
-            </a:pPr>
-            <a:r>
-              <a:t>Step 2: extract value — opcodes: {call, lea, mov}</a:t>
+                  <a:srgbClr val="CF222E"/>
+                </a:solidFill>
+                <a:latin typeface="Calibri"/>
+              </a:defRPr>
+            </a:pPr>
+            <a:r>
+              <a:t>panic block: lea panic_msg + call panic — opcodes: {call, lea, mov}</a:t>
             </a:r>
           </a:p>
           <a:p>
@@ -11489,19 +11716,15 @@
               </a:defRPr>
             </a:pPr>
             <a:r>
-              <a:t>mov      rsi, qword ptr [rsp + 0xc8]</a:t>
-            </a:r>
-            <a:br/>
-            <a:r>
-              <a:t>lea      rdi, [rsp + 0xe8]</a:t>
-            </a:r>
-            <a:br/>
-            <a:r>
-              <a:t>mov      qword ptr [rsp + 0xd0], rdi</a:t>
-            </a:r>
-            <a:br/>
-            <a:r>
-              <a:t>call     0x42efa0</a:t>
+              <a:t>lea      rdi, [rip + 0x4d39d]</a:t>
+            </a:r>
+            <a:br/>
+            <a:r>
+              <a:t>mov      rax, qword ptr [rip + 0x506fe]</a:t>
+            </a:r>
+            <a:br/>
+            <a:r>
+              <a:t>call     rax</a:t>
             </a:r>
           </a:p>
         </p:txBody>
@@ -11514,8 +11737,8 @@
         </p:nvSpPr>
         <p:spPr>
           <a:xfrm>
-            <a:off x="274320" y="5477256"/>
-            <a:ext cx="4572000" cy="694944"/>
+            <a:off x="274320" y="5513832"/>
+            <a:ext cx="4572000" cy="841248"/>
           </a:xfrm>
           <a:prstGeom prst="roundRect">
             <a:avLst/>
@@ -11553,13 +11776,13 @@
               </a:spcAft>
               <a:defRPr sz="1300" b="1">
                 <a:solidFill>
-                  <a:srgbClr val="CF222E"/>
-                </a:solidFill>
-                <a:latin typeface="Calibri"/>
-              </a:defRPr>
-            </a:pPr>
-            <a:r>
-              <a:t>Step 3: panic if None — opcodes: {call, lea, mov} ← SAME!</a:t>
+                  <a:srgbClr val="0E5AAB"/>
+                </a:solidFill>
+                <a:latin typeface="Calibri"/>
+              </a:defRPr>
+            </a:pPr>
+            <a:r>
+              <a:t>normal call block (collect) — opcodes: {call, lea, mov} ← SAME!</a:t>
             </a:r>
           </a:p>
           <a:p>
@@ -11572,15 +11795,19 @@
               </a:defRPr>
             </a:pPr>
             <a:r>
-              <a:t>lea      rdi, [rip + 0x4d39d]</a:t>
-            </a:r>
-            <a:br/>
-            <a:r>
-              <a:t>mov      rax, qword ptr [rip + 0x506fe]</a:t>
-            </a:r>
-            <a:br/>
-            <a:r>
-              <a:t>call     rax</a:t>
+              <a:t>mov      rsi, qword ptr [rsp + 0xc8]</a:t>
+            </a:r>
+            <a:br/>
+            <a:r>
+              <a:t>lea      rdi, [rsp + 0xe8]</a:t>
+            </a:r>
+            <a:br/>
+            <a:r>
+              <a:t>mov      qword ptr [rsp + 0xd0], rdi</a:t>
+            </a:r>
+            <a:br/>
+            <a:r>
+              <a:t>call     0x42efa0</a:t>
             </a:r>
           </a:p>
         </p:txBody>
@@ -11593,7 +11820,7 @@
         </p:nvSpPr>
         <p:spPr>
           <a:xfrm>
-            <a:off x="274320" y="6217920"/>
+            <a:off x="274320" y="6400800"/>
             <a:ext cx="5303520" cy="457200"/>
           </a:xfrm>
           <a:prstGeom prst="rect">
@@ -11616,7 +11843,7 @@
               </a:defRPr>
             </a:pPr>
             <a:r>
-              <a:t>↑ Steps 2 &amp; 3: same opcodes — matcher can't see call target → confuses panic with normal calls</a:t>
+              <a:t>↑ Panic block and normal call block: same opcodes {call, lea, mov} — matcher can't distinguish</a:t>
             </a:r>
           </a:p>
         </p:txBody>
@@ -11747,7 +11974,7 @@
               </a:defRPr>
             </a:pPr>
             <a:r>
-              <a:t>C assembly — diverse block types:</a:t>
+              <a:t>C assembly — no panic paths, blocks are diverse:</a:t>
             </a:r>
           </a:p>
         </p:txBody>
@@ -11805,7 +12032,7 @@
               </a:defRPr>
             </a:pPr>
             <a:r>
-              <a:t>BODY (5 insns)</a:t>
+              <a:t>5 insns (line 1282)</a:t>
             </a:r>
           </a:p>
           <a:p>
@@ -11892,7 +12119,7 @@
               </a:defRPr>
             </a:pPr>
             <a:r>
-              <a:t>BODY (2 insns)</a:t>
+              <a:t>2 insns (line 1283)</a:t>
             </a:r>
           </a:p>
           <a:p>
@@ -11981,7 +12208,7 @@
               </a:defRPr>
             </a:pPr>
             <a:r>
-              <a:t>pu_08: 43 O0 blocks, only 10 unique opcode sets. 11 share {call, lea, mov}, 12 share {jmp, mov}. Only 2/43 correct.</a:t>
+              <a:t>pu_08 Rust O0: 43 blocks, only 10 unique opcode sets. 11× {call, lea, mov}, 12× {jmp, mov}. Matcher can't tell them apart.</a:t>
             </a:r>
           </a:p>
         </p:txBody>
@@ -12255,21 +12482,25 @@
               </a:defRPr>
             </a:pPr>
             <a:r>
-              <a:t>3× .unwrap() = 9+ blocks</a:t>
-            </a:r>
-            <a:br/>
-            <a:r>
-              <a:t>all sharing {call, lea, mov}.</a:t>
-            </a:r>
-            <a:br/>
-            <a:br/>
-            <a:r>
-              <a:t>Only 2/43 matched correctly.</a:t>
-            </a:r>
-            <a:br/>
-            <a:br/>
-            <a:r>
-              <a:t>C has no panic paths →</a:t>
+              <a:t>3× .unwrap() = 3 panic blocks</a:t>
+            </a:r>
+            <a:br/>
+            <a:r>
+              <a:t>each with {call, lea, mov}.</a:t>
+            </a:r>
+            <a:br/>
+            <a:br/>
+            <a:r>
+              <a:t>11 blocks share {call, lea, mov}</a:t>
+            </a:r>
+            <a:br/>
+            <a:r>
+              <a:t>(panic + normal calls mixed).</a:t>
+            </a:r>
+            <a:br/>
+            <a:br/>
+            <a:r>
+              <a:t>C: no panic paths →</a:t>
             </a:r>
             <a:br/>
             <a:r>

</xml_diff>